<commit_message>
Fix slide 10 outcome label overlap
</commit_message>
<xml_diff>
--- a/submissions/track2-quakesense/docs/QuakeSense_AMD_Track2_Deck_EN.pptx
+++ b/submissions/track2-quakesense/docs/QuakeSense_AMD_Track2_Deck_EN.pptx
@@ -2,28 +2,28 @@
 <file path=ppt/presentation.xml><?xml version="1.0" encoding="utf-8"?>
 <p:presentation xmlns:p="http://schemas.openxmlformats.org/presentationml/2006/main">
   <p:sldMasterIdLst>
-    <p:sldMasterId xmlns:r="http://schemas.openxmlformats.org/officeDocument/2006/relationships" id="2147483648" r:id="R1f89bc50cd574dd2"/>
+    <p:sldMasterId xmlns:r="http://schemas.openxmlformats.org/officeDocument/2006/relationships" id="2147483648" r:id="Rd749dd1fd32543bf"/>
   </p:sldMasterIdLst>
   <p:notesMasterIdLst>
-    <p:notesMasterId xmlns:r="http://schemas.openxmlformats.org/officeDocument/2006/relationships" r:id="R66631a53aa0a4377"/>
+    <p:notesMasterId xmlns:r="http://schemas.openxmlformats.org/officeDocument/2006/relationships" r:id="R77cc7e66b7b14fec"/>
   </p:notesMasterIdLst>
   <p:sldIdLst>
-    <p:sldId xmlns:r="http://schemas.openxmlformats.org/officeDocument/2006/relationships" id="256" r:id="Rb1385acb0ad94418"/>
-    <p:sldId xmlns:r="http://schemas.openxmlformats.org/officeDocument/2006/relationships" id="257" r:id="R1b3d4e0ff2684139"/>
-    <p:sldId xmlns:r="http://schemas.openxmlformats.org/officeDocument/2006/relationships" id="258" r:id="Rc8d7a54f3d854d56"/>
-    <p:sldId xmlns:r="http://schemas.openxmlformats.org/officeDocument/2006/relationships" id="259" r:id="Rf746bf08ec074510"/>
-    <p:sldId xmlns:r="http://schemas.openxmlformats.org/officeDocument/2006/relationships" id="260" r:id="R962abf3013254378"/>
-    <p:sldId xmlns:r="http://schemas.openxmlformats.org/officeDocument/2006/relationships" id="261" r:id="R6597e2ce027745bb"/>
-    <p:sldId xmlns:r="http://schemas.openxmlformats.org/officeDocument/2006/relationships" id="262" r:id="R7169ba685bd54fb3"/>
-    <p:sldId xmlns:r="http://schemas.openxmlformats.org/officeDocument/2006/relationships" id="263" r:id="R60dc1f4278fc42d0"/>
-    <p:sldId xmlns:r="http://schemas.openxmlformats.org/officeDocument/2006/relationships" id="264" r:id="R11310f33da24449c"/>
-    <p:sldId xmlns:r="http://schemas.openxmlformats.org/officeDocument/2006/relationships" id="265" r:id="R4649bfaa92b048d0"/>
-    <p:sldId xmlns:r="http://schemas.openxmlformats.org/officeDocument/2006/relationships" id="266" r:id="Ra6b92c16b43d40af"/>
-    <p:sldId xmlns:r="http://schemas.openxmlformats.org/officeDocument/2006/relationships" id="267" r:id="Rb38c12688d564836"/>
-    <p:sldId xmlns:r="http://schemas.openxmlformats.org/officeDocument/2006/relationships" id="268" r:id="Ra36cdb5974814389"/>
-    <p:sldId xmlns:r="http://schemas.openxmlformats.org/officeDocument/2006/relationships" id="269" r:id="Rf8fa2a59c583453d"/>
-    <p:sldId xmlns:r="http://schemas.openxmlformats.org/officeDocument/2006/relationships" id="270" r:id="Ra6016c1612de400a"/>
-    <p:sldId xmlns:r="http://schemas.openxmlformats.org/officeDocument/2006/relationships" id="271" r:id="Re87302fd222c4dc1"/>
+    <p:sldId xmlns:r="http://schemas.openxmlformats.org/officeDocument/2006/relationships" id="256" r:id="Rac63c2c3ae2440dc"/>
+    <p:sldId xmlns:r="http://schemas.openxmlformats.org/officeDocument/2006/relationships" id="257" r:id="R69af74fb2ca9415d"/>
+    <p:sldId xmlns:r="http://schemas.openxmlformats.org/officeDocument/2006/relationships" id="258" r:id="R1a8ce4bed19643c4"/>
+    <p:sldId xmlns:r="http://schemas.openxmlformats.org/officeDocument/2006/relationships" id="259" r:id="Rc089ff81a7a3409f"/>
+    <p:sldId xmlns:r="http://schemas.openxmlformats.org/officeDocument/2006/relationships" id="260" r:id="R28efae611a4d47b1"/>
+    <p:sldId xmlns:r="http://schemas.openxmlformats.org/officeDocument/2006/relationships" id="261" r:id="R0bd1c1c2f3324b00"/>
+    <p:sldId xmlns:r="http://schemas.openxmlformats.org/officeDocument/2006/relationships" id="262" r:id="R8c78eff1e09d45dd"/>
+    <p:sldId xmlns:r="http://schemas.openxmlformats.org/officeDocument/2006/relationships" id="263" r:id="Rccae59f34bd346c2"/>
+    <p:sldId xmlns:r="http://schemas.openxmlformats.org/officeDocument/2006/relationships" id="264" r:id="Rbd5ab6492dbc4b41"/>
+    <p:sldId xmlns:r="http://schemas.openxmlformats.org/officeDocument/2006/relationships" id="265" r:id="R573d217849f24f9e"/>
+    <p:sldId xmlns:r="http://schemas.openxmlformats.org/officeDocument/2006/relationships" id="266" r:id="Rbf15c80f39064153"/>
+    <p:sldId xmlns:r="http://schemas.openxmlformats.org/officeDocument/2006/relationships" id="267" r:id="R736acec5ef774c82"/>
+    <p:sldId xmlns:r="http://schemas.openxmlformats.org/officeDocument/2006/relationships" id="268" r:id="Rb1d768a5d8a948a0"/>
+    <p:sldId xmlns:r="http://schemas.openxmlformats.org/officeDocument/2006/relationships" id="269" r:id="Rdb753aed0f1b45f3"/>
+    <p:sldId xmlns:r="http://schemas.openxmlformats.org/officeDocument/2006/relationships" id="270" r:id="Rbde73b30ced44ba6"/>
+    <p:sldId xmlns:r="http://schemas.openxmlformats.org/officeDocument/2006/relationships" id="271" r:id="R40c7ca6fef1247e1"/>
   </p:sldIdLst>
   <p:sldSz cx="12192000" cy="6858000"/>
   <p:notesSz cx="6858000" cy="9144000"/>
@@ -1910,7 +1910,7 @@
   </p:cSld>
   <p:clrMap bg1="lt1" tx1="dk1" bg2="lt2" tx2="dk2" accent1="accent1" accent2="accent2" accent3="accent3" accent4="accent4" accent5="accent5" accent6="accent6" hlink="hlink" folHlink="folHlink"/>
   <p:sldLayoutIdLst>
-    <p:sldLayoutId xmlns:r="http://schemas.openxmlformats.org/officeDocument/2006/relationships" id="2147483649" r:id="Rffa658a411d1408d"/>
+    <p:sldLayoutId xmlns:r="http://schemas.openxmlformats.org/officeDocument/2006/relationships" id="2147483649" r:id="R27a7cb01ac814942"/>
   </p:sldLayoutIdLst>
   <p:txStyles>
     <p:titleStyle>
@@ -2465,7 +2465,7 @@
           <p:nvPr/>
         </p:nvPicPr>
         <p:blipFill>
-          <a:blip xmlns:r="http://schemas.openxmlformats.org/officeDocument/2006/relationships" xmlns:a="http://schemas.openxmlformats.org/drawingml/2006/main" r:embed="R968d66539ac946e7"/>
+          <a:blip xmlns:r="http://schemas.openxmlformats.org/officeDocument/2006/relationships" xmlns:a="http://schemas.openxmlformats.org/drawingml/2006/main" r:embed="R2e75b718e0cc4a64"/>
           <a:srcRect xmlns:a="http://schemas.openxmlformats.org/drawingml/2006/main" l="15700" t="0" r="15700" b="0"/>
           <a:stretch xmlns:a="http://schemas.openxmlformats.org/drawingml/2006/main">
             <a:fillRect l="0" t="0" r="0" b="0"/>
@@ -3178,8 +3178,8 @@
         </p:nvSpPr>
         <p:spPr>
           <a:xfrm xmlns:a="http://schemas.openxmlformats.org/drawingml/2006/main">
-            <a:off x="9353550" y="1676400"/>
-            <a:ext cx="1428750" cy="266700"/>
+            <a:off x="8896350" y="1676400"/>
+            <a:ext cx="876300" cy="266700"/>
           </a:xfrm>
           <a:prstGeom xmlns:a="http://schemas.openxmlformats.org/drawingml/2006/main" prst="rect">
             <a:avLst/>
@@ -3379,8 +3379,8 @@
         </p:nvSpPr>
         <p:spPr>
           <a:xfrm xmlns:a="http://schemas.openxmlformats.org/drawingml/2006/main">
-            <a:off x="9353550" y="2152650"/>
-            <a:ext cx="1428750" cy="266700"/>
+            <a:off x="8896350" y="2152650"/>
+            <a:ext cx="876300" cy="266700"/>
           </a:xfrm>
           <a:prstGeom xmlns:a="http://schemas.openxmlformats.org/drawingml/2006/main" prst="rect">
             <a:avLst/>
@@ -3580,8 +3580,8 @@
         </p:nvSpPr>
         <p:spPr>
           <a:xfrm xmlns:a="http://schemas.openxmlformats.org/drawingml/2006/main">
-            <a:off x="9353550" y="2628900"/>
-            <a:ext cx="1428750" cy="266700"/>
+            <a:off x="8896350" y="2628900"/>
+            <a:ext cx="876300" cy="266700"/>
           </a:xfrm>
           <a:prstGeom xmlns:a="http://schemas.openxmlformats.org/drawingml/2006/main" prst="rect">
             <a:avLst/>
@@ -3781,8 +3781,8 @@
         </p:nvSpPr>
         <p:spPr>
           <a:xfrm xmlns:a="http://schemas.openxmlformats.org/drawingml/2006/main">
-            <a:off x="9353550" y="3105150"/>
-            <a:ext cx="1428750" cy="266700"/>
+            <a:off x="8896350" y="3105150"/>
+            <a:ext cx="876300" cy="266700"/>
           </a:xfrm>
           <a:prstGeom xmlns:a="http://schemas.openxmlformats.org/drawingml/2006/main" prst="rect">
             <a:avLst/>
@@ -3982,8 +3982,8 @@
         </p:nvSpPr>
         <p:spPr>
           <a:xfrm xmlns:a="http://schemas.openxmlformats.org/drawingml/2006/main">
-            <a:off x="9353550" y="3581400"/>
-            <a:ext cx="1428750" cy="266700"/>
+            <a:off x="8896350" y="3581400"/>
+            <a:ext cx="876300" cy="266700"/>
           </a:xfrm>
           <a:prstGeom xmlns:a="http://schemas.openxmlformats.org/drawingml/2006/main" prst="rect">
             <a:avLst/>
@@ -4183,8 +4183,8 @@
         </p:nvSpPr>
         <p:spPr>
           <a:xfrm xmlns:a="http://schemas.openxmlformats.org/drawingml/2006/main">
-            <a:off x="9353550" y="4057650"/>
-            <a:ext cx="1428750" cy="266700"/>
+            <a:off x="8896350" y="4057650"/>
+            <a:ext cx="876300" cy="266700"/>
           </a:xfrm>
           <a:prstGeom xmlns:a="http://schemas.openxmlformats.org/drawingml/2006/main" prst="rect">
             <a:avLst/>
@@ -4384,8 +4384,8 @@
         </p:nvSpPr>
         <p:spPr>
           <a:xfrm xmlns:a="http://schemas.openxmlformats.org/drawingml/2006/main">
-            <a:off x="9353550" y="4533900"/>
-            <a:ext cx="1428750" cy="266700"/>
+            <a:off x="8896350" y="4533900"/>
+            <a:ext cx="876300" cy="266700"/>
           </a:xfrm>
           <a:prstGeom xmlns:a="http://schemas.openxmlformats.org/drawingml/2006/main" prst="rect">
             <a:avLst/>
@@ -4585,8 +4585,8 @@
         </p:nvSpPr>
         <p:spPr>
           <a:xfrm xmlns:a="http://schemas.openxmlformats.org/drawingml/2006/main">
-            <a:off x="9353550" y="5010150"/>
-            <a:ext cx="1428750" cy="266700"/>
+            <a:off x="8896350" y="5010150"/>
+            <a:ext cx="876300" cy="266700"/>
           </a:xfrm>
           <a:prstGeom xmlns:a="http://schemas.openxmlformats.org/drawingml/2006/main" prst="rect">
             <a:avLst/>
@@ -5220,7 +5220,7 @@
           <p:nvPr/>
         </p:nvPicPr>
         <p:blipFill>
-          <a:blip xmlns:r="http://schemas.openxmlformats.org/officeDocument/2006/relationships" xmlns:a="http://schemas.openxmlformats.org/drawingml/2006/main" r:embed="R0718b06358c6410f"/>
+          <a:blip xmlns:r="http://schemas.openxmlformats.org/officeDocument/2006/relationships" xmlns:a="http://schemas.openxmlformats.org/drawingml/2006/main" r:embed="Rdc161ffa34974009"/>
           <a:srcRect xmlns:a="http://schemas.openxmlformats.org/drawingml/2006/main" l="0" t="11048" r="0" b="11048"/>
           <a:stretch xmlns:a="http://schemas.openxmlformats.org/drawingml/2006/main">
             <a:fillRect l="0" t="0" r="0" b="0"/>
@@ -5466,7 +5466,7 @@
           <p:nvPr/>
         </p:nvPicPr>
         <p:blipFill>
-          <a:blip xmlns:r="http://schemas.openxmlformats.org/officeDocument/2006/relationships" xmlns:a="http://schemas.openxmlformats.org/drawingml/2006/main" r:embed="Rf88af77bebe54fd1"/>
+          <a:blip xmlns:r="http://schemas.openxmlformats.org/officeDocument/2006/relationships" xmlns:a="http://schemas.openxmlformats.org/drawingml/2006/main" r:embed="R9046e93a48db4b40"/>
           <a:srcRect xmlns:a="http://schemas.openxmlformats.org/drawingml/2006/main" l="0" t="11048" r="0" b="11048"/>
           <a:stretch xmlns:a="http://schemas.openxmlformats.org/drawingml/2006/main">
             <a:fillRect l="0" t="0" r="0" b="0"/>
@@ -5712,7 +5712,7 @@
           <p:nvPr/>
         </p:nvPicPr>
         <p:blipFill>
-          <a:blip xmlns:r="http://schemas.openxmlformats.org/officeDocument/2006/relationships" xmlns:a="http://schemas.openxmlformats.org/drawingml/2006/main" r:embed="R1e9073522cf64a96"/>
+          <a:blip xmlns:r="http://schemas.openxmlformats.org/officeDocument/2006/relationships" xmlns:a="http://schemas.openxmlformats.org/drawingml/2006/main" r:embed="Raeef0daac79d4e32"/>
           <a:srcRect xmlns:a="http://schemas.openxmlformats.org/drawingml/2006/main" l="0" t="11048" r="0" b="11048"/>
           <a:stretch xmlns:a="http://schemas.openxmlformats.org/drawingml/2006/main">
             <a:fillRect l="0" t="0" r="0" b="0"/>
@@ -20044,7 +20044,7 @@
           <p:nvPr/>
         </p:nvPicPr>
         <p:blipFill>
-          <a:blip xmlns:r="http://schemas.openxmlformats.org/officeDocument/2006/relationships" xmlns:a="http://schemas.openxmlformats.org/drawingml/2006/main" r:embed="R9c86622222bf43df"/>
+          <a:blip xmlns:r="http://schemas.openxmlformats.org/officeDocument/2006/relationships" xmlns:a="http://schemas.openxmlformats.org/drawingml/2006/main" r:embed="R4b131f9d3ad44362"/>
           <a:srcRect xmlns:a="http://schemas.openxmlformats.org/drawingml/2006/main" l="2288" t="0" r="2288" b="0"/>
           <a:stretch xmlns:a="http://schemas.openxmlformats.org/drawingml/2006/main">
             <a:fillRect l="0" t="0" r="0" b="0"/>
@@ -21045,7 +21045,7 @@
           <p:nvPr/>
         </p:nvPicPr>
         <p:blipFill>
-          <a:blip xmlns:r="http://schemas.openxmlformats.org/officeDocument/2006/relationships" xmlns:a="http://schemas.openxmlformats.org/drawingml/2006/main" r:embed="Rfbdada75483242a6"/>
+          <a:blip xmlns:r="http://schemas.openxmlformats.org/officeDocument/2006/relationships" xmlns:a="http://schemas.openxmlformats.org/drawingml/2006/main" r:embed="Rbfca92af431c43fb"/>
           <a:srcRect xmlns:a="http://schemas.openxmlformats.org/drawingml/2006/main" l="0" t="11809" r="0" b="11809"/>
           <a:stretch xmlns:a="http://schemas.openxmlformats.org/drawingml/2006/main">
             <a:fillRect l="0" t="0" r="0" b="0"/>

</xml_diff>